<commit_message>
docs: update PPT with presenter name and DevOps Engineer title
</commit_message>
<xml_diff>
--- a/docs/VulnInt-Presentation.pptx
+++ b/docs/VulnInt-Presentation.pptx
@@ -1556,8 +1556,8 @@
         </p:blipFill>
         <p:spPr>
           <a:xfrm>
-            <a:off x="731520" y="914400"/>
-            <a:ext cx="640080" cy="640080"/>
+            <a:off x="731520" y="548640"/>
+            <a:ext cx="502920" cy="502920"/>
           </a:xfrm>
           <a:prstGeom prst="rect">
             <a:avLst/>
@@ -1572,8 +1572,8 @@
         </p:nvSpPr>
         <p:spPr>
           <a:xfrm>
-            <a:off x="731520" y="1645920"/>
-            <a:ext cx="7315200" cy="914400"/>
+            <a:off x="731520" y="1143000"/>
+            <a:ext cx="7315200" cy="777240"/>
           </a:xfrm>
           <a:prstGeom prst="rect">
             <a:avLst/>
@@ -1589,7 +1589,7 @@
               <a:buNone/>
             </a:pPr>
             <a:r>
-              <a:rPr lang="en-US" sz="4800" b="1" dirty="0">
+              <a:rPr lang="en-US" sz="4400" b="1" dirty="0">
                 <a:solidFill>
                   <a:srgbClr val="FFFFFF"/>
                 </a:solidFill>
@@ -1599,7 +1599,7 @@
               </a:rPr>
               <a:t>VulnInt</a:t>
             </a:r>
-            <a:endParaRPr lang="en-US" sz="4800" dirty="0"/>
+            <a:endParaRPr lang="en-US" sz="4400" dirty="0"/>
           </a:p>
         </p:txBody>
       </p:sp>
@@ -1611,8 +1611,8 @@
         </p:nvSpPr>
         <p:spPr>
           <a:xfrm>
-            <a:off x="731520" y="2423160"/>
-            <a:ext cx="7315200" cy="457200"/>
+            <a:off x="731520" y="1828800"/>
+            <a:ext cx="7315200" cy="365760"/>
           </a:xfrm>
           <a:prstGeom prst="rect">
             <a:avLst/>
@@ -1628,7 +1628,7 @@
               <a:buNone/>
             </a:pPr>
             <a:r>
-              <a:rPr lang="en-US" sz="1800" dirty="0">
+              <a:rPr lang="en-US" sz="1600" dirty="0">
                 <a:solidFill>
                   <a:srgbClr val="94A3B8"/>
                 </a:solidFill>
@@ -1638,59 +1638,59 @@
               </a:rPr>
               <a:t>Vulnerability Intelligence &amp; Management Platform</a:t>
             </a:r>
+            <a:endParaRPr lang="en-US" sz="1600" dirty="0"/>
+          </a:p>
+        </p:txBody>
+      </p:sp>
+      <p:sp>
+        <p:nvSpPr>
+          <p:cNvPr id="7" name="Text 4"/>
+          <p:cNvSpPr/>
+          <p:nvPr/>
+        </p:nvSpPr>
+        <p:spPr>
+          <a:xfrm>
+            <a:off x="731520" y="2240280"/>
+            <a:ext cx="7315200" cy="320040"/>
+          </a:xfrm>
+          <a:prstGeom prst="rect">
+            <a:avLst/>
+          </a:prstGeom>
+          <a:noFill/>
+          <a:ln/>
+        </p:spPr>
+        <p:txBody>
+          <a:bodyPr wrap="square" lIns="0" tIns="0" rIns="0" bIns="0" rtlCol="0" anchor="ctr"/>
+          <a:lstStyle/>
+          <a:p>
+            <a:pPr indent="0" marL="0">
+              <a:buNone/>
+            </a:pPr>
+            <a:r>
+              <a:rPr lang="en-US" sz="1800" i="1" dirty="0">
+                <a:solidFill>
+                  <a:srgbClr val="0EA5E9"/>
+                </a:solidFill>
+                <a:latin typeface="Calibri" pitchFamily="34" charset="0"/>
+                <a:ea typeface="Calibri" pitchFamily="34" charset="-122"/>
+                <a:cs typeface="Calibri" pitchFamily="34" charset="-120"/>
+              </a:rPr>
+              <a:t>Keamanan Server Anda, Terpantau 24/7</a:t>
+            </a:r>
             <a:endParaRPr lang="en-US" sz="1800" dirty="0"/>
           </a:p>
         </p:txBody>
       </p:sp>
       <p:sp>
         <p:nvSpPr>
-          <p:cNvPr id="7" name="Text 4"/>
-          <p:cNvSpPr/>
-          <p:nvPr/>
-        </p:nvSpPr>
-        <p:spPr>
-          <a:xfrm>
-            <a:off x="731520" y="2926080"/>
-            <a:ext cx="7315200" cy="457200"/>
-          </a:xfrm>
-          <a:prstGeom prst="rect">
-            <a:avLst/>
-          </a:prstGeom>
-          <a:noFill/>
-          <a:ln/>
-        </p:spPr>
-        <p:txBody>
-          <a:bodyPr wrap="square" lIns="0" tIns="0" rIns="0" bIns="0" rtlCol="0" anchor="ctr"/>
-          <a:lstStyle/>
-          <a:p>
-            <a:pPr indent="0" marL="0">
-              <a:buNone/>
-            </a:pPr>
-            <a:r>
-              <a:rPr lang="en-US" sz="2000" i="1" dirty="0">
-                <a:solidFill>
-                  <a:srgbClr val="0EA5E9"/>
-                </a:solidFill>
-                <a:latin typeface="Calibri" pitchFamily="34" charset="0"/>
-                <a:ea typeface="Calibri" pitchFamily="34" charset="-122"/>
-                <a:cs typeface="Calibri" pitchFamily="34" charset="-120"/>
-              </a:rPr>
-              <a:t>Keamanan Server Anda, Terpantau 24/7</a:t>
-            </a:r>
-            <a:endParaRPr lang="en-US" sz="2000" dirty="0"/>
-          </a:p>
-        </p:txBody>
-      </p:sp>
-      <p:sp>
-        <p:nvSpPr>
           <p:cNvPr id="8" name="Shape 5"/>
           <p:cNvSpPr/>
           <p:nvPr/>
         </p:nvSpPr>
         <p:spPr>
           <a:xfrm>
-            <a:off x="0" y="4754880"/>
-            <a:ext cx="9144000" cy="388620"/>
+            <a:off x="731520" y="3017520"/>
+            <a:ext cx="3474720" cy="731520"/>
           </a:xfrm>
           <a:prstGeom prst="rect">
             <a:avLst/>
@@ -1699,11 +1699,136 @@
             <a:srgbClr val="151923"/>
           </a:solidFill>
           <a:ln/>
-        </p:spPr>
-      </p:sp>
-      <p:sp>
-        <p:nvSpPr>
-          <p:cNvPr id="9" name="Text 6"/>
+          <a:effectLst>
+            <a:outerShdw sx="100000" sy="100000" kx="0" ky="0" algn="bl" rotWithShape="0" blurRad="101600" dist="25400" dir="8100000">
+              <a:srgbClr val="000000">
+                <a:alpha val="30000"/>
+              </a:srgbClr>
+            </a:outerShdw>
+          </a:effectLst>
+        </p:spPr>
+      </p:sp>
+      <p:sp>
+        <p:nvSpPr>
+          <p:cNvPr id="9" name="Shape 6"/>
+          <p:cNvSpPr/>
+          <p:nvPr/>
+        </p:nvSpPr>
+        <p:spPr>
+          <a:xfrm>
+            <a:off x="731520" y="3017520"/>
+            <a:ext cx="54864" cy="731520"/>
+          </a:xfrm>
+          <a:prstGeom prst="rect">
+            <a:avLst/>
+          </a:prstGeom>
+          <a:solidFill>
+            <a:srgbClr val="3B82F6"/>
+          </a:solidFill>
+          <a:ln/>
+        </p:spPr>
+      </p:sp>
+      <p:sp>
+        <p:nvSpPr>
+          <p:cNvPr id="10" name="Text 7"/>
+          <p:cNvSpPr/>
+          <p:nvPr/>
+        </p:nvSpPr>
+        <p:spPr>
+          <a:xfrm>
+            <a:off x="1005840" y="3063240"/>
+            <a:ext cx="3017520" cy="320040"/>
+          </a:xfrm>
+          <a:prstGeom prst="rect">
+            <a:avLst/>
+          </a:prstGeom>
+          <a:noFill/>
+          <a:ln/>
+        </p:spPr>
+        <p:txBody>
+          <a:bodyPr wrap="square" lIns="0" tIns="0" rIns="0" bIns="0" rtlCol="0" anchor="ctr"/>
+          <a:lstStyle/>
+          <a:p>
+            <a:pPr indent="0" marL="0">
+              <a:buNone/>
+            </a:pPr>
+            <a:r>
+              <a:rPr lang="en-US" sz="1700" b="1" dirty="0">
+                <a:solidFill>
+                  <a:srgbClr val="FFFFFF"/>
+                </a:solidFill>
+                <a:latin typeface="Calibri" pitchFamily="34" charset="0"/>
+                <a:ea typeface="Calibri" pitchFamily="34" charset="-122"/>
+                <a:cs typeface="Calibri" pitchFamily="34" charset="-120"/>
+              </a:rPr>
+              <a:t>Lilik Giri Rezando</a:t>
+            </a:r>
+            <a:endParaRPr lang="en-US" sz="1700" dirty="0"/>
+          </a:p>
+        </p:txBody>
+      </p:sp>
+      <p:sp>
+        <p:nvSpPr>
+          <p:cNvPr id="11" name="Text 8"/>
+          <p:cNvSpPr/>
+          <p:nvPr/>
+        </p:nvSpPr>
+        <p:spPr>
+          <a:xfrm>
+            <a:off x="1005840" y="3401568"/>
+            <a:ext cx="3017520" cy="256032"/>
+          </a:xfrm>
+          <a:prstGeom prst="rect">
+            <a:avLst/>
+          </a:prstGeom>
+          <a:noFill/>
+          <a:ln/>
+        </p:spPr>
+        <p:txBody>
+          <a:bodyPr wrap="square" lIns="0" tIns="0" rIns="0" bIns="0" rtlCol="0" anchor="ctr"/>
+          <a:lstStyle/>
+          <a:p>
+            <a:pPr indent="0" marL="0">
+              <a:buNone/>
+            </a:pPr>
+            <a:r>
+              <a:rPr lang="en-US" sz="1300" dirty="0">
+                <a:solidFill>
+                  <a:srgbClr val="3B82F6"/>
+                </a:solidFill>
+                <a:latin typeface="Calibri" pitchFamily="34" charset="0"/>
+                <a:ea typeface="Calibri" pitchFamily="34" charset="-122"/>
+                <a:cs typeface="Calibri" pitchFamily="34" charset="-120"/>
+              </a:rPr>
+              <a:t>DevOps Engineer</a:t>
+            </a:r>
+            <a:endParaRPr lang="en-US" sz="1300" dirty="0"/>
+          </a:p>
+        </p:txBody>
+      </p:sp>
+      <p:sp>
+        <p:nvSpPr>
+          <p:cNvPr id="12" name="Shape 9"/>
+          <p:cNvSpPr/>
+          <p:nvPr/>
+        </p:nvSpPr>
+        <p:spPr>
+          <a:xfrm>
+            <a:off x="0" y="4754880"/>
+            <a:ext cx="9144000" cy="388620"/>
+          </a:xfrm>
+          <a:prstGeom prst="rect">
+            <a:avLst/>
+          </a:prstGeom>
+          <a:solidFill>
+            <a:srgbClr val="151923"/>
+          </a:solidFill>
+          <a:ln/>
+        </p:spPr>
+      </p:sp>
+      <p:sp>
+        <p:nvSpPr>
+          <p:cNvPr id="13" name="Text 10"/>
           <p:cNvSpPr/>
           <p:nvPr/>
         </p:nvSpPr>
@@ -7151,7 +7276,7 @@
                 <a:ea typeface="Calibri" pitchFamily="34" charset="-122"/>
                 <a:cs typeface="Calibri" pitchFamily="34" charset="-120"/>
               </a:rPr>
-              <a:t>Agent hanya koneksi keluar via HTTPS. Tidak perlu buka port inbound di server — aman untuk production environment.</a:t>
+              <a:t>Agent hanya koneksi keluar via HTTPS. Tidak perlu buka port inbound di server — aman untuk production.</a:t>
             </a:r>
             <a:endParaRPr lang="en-US" sz="1100" dirty="0"/>
           </a:p>

</xml_diff>